<commit_message>
add project of iti
</commit_message>
<xml_diff>
--- a/projects/ai-customer-feedback-intelligence-system/docs/Presentation_Project.pptx
+++ b/projects/ai-customer-feedback-intelligence-system/docs/Presentation_Project.pptx
@@ -221,10 +221,10 @@
                 <c:formatCode>0.0</c:formatCode>
                 <c:ptCount val="2"/>
                 <c:pt idx="0">
-                  <c:v>82.0</c:v>
+                  <c:v>82.1</c:v>
                 </c:pt>
                 <c:pt idx="1">
-                  <c:v>78.5</c:v>
+                  <c:v>78.3</c:v>
                 </c:pt>
               </c:numCache>
             </c:numRef>
@@ -2535,7 +2535,7 @@
                 <a:ea typeface="Calibri" panose="020F0502020204030204" pitchFamily="34" charset="-122"/>
                 <a:cs typeface="Calibri" panose="020F0502020204030204" pitchFamily="34" charset="-120"/>
               </a:rPr>
-              <a:t>5 interpreted themes: fabric/material quality (743 reviews, the largest), sizing small/large (569), dress disappointment (435), look/appearance mismatch (420), and boxy/short fit (202)</a:t>
+              <a:t>5 interpreted themes: fabric/material quality (735 reviews, the largest), look/appearance mismatch (544), sizing small/large (471), dress disappointment (428), and boxy/short fit (191)</a:t>
             </a:r>
             <a:endParaRPr lang="en-US" sz="1300" dirty="0"/>
           </a:p>
@@ -2889,7 +2889,7 @@
                 <a:ea typeface="Calibri" panose="020F0502020204030204" pitchFamily="34" charset="-122"/>
                 <a:cs typeface="Calibri" panose="020F0502020204030204" pitchFamily="34" charset="-120"/>
               </a:rPr>
-              <a:t>Logistic Regression is the strongest model; class_weight='balanced' lifts Negative recall from 0.41 to 0.58 and Macro F1 to 0.60, at the cost of overall accuracy (82.0% → 77.1%)</a:t>
+              <a:t>Logistic Regression is the strongest model; class_weight='balanced' lifts Negative recall from 0.41 to 0.57 and Macro F1 to 0.60, at the cost of overall accuracy (82.1% → 77.0%)</a:t>
             </a:r>
             <a:endParaRPr lang="en-US" sz="1500" dirty="0"/>
           </a:p>
@@ -6582,7 +6582,7 @@
                 <a:ea typeface="Calibri" panose="020F0502020204030204" pitchFamily="34" charset="-122"/>
                 <a:cs typeface="Calibri" panose="020F0502020204030204" pitchFamily="34" charset="-120"/>
               </a:rPr>
-              <a:t>LOGISTIC REGRESSION — 82.0% ACCURACY</a:t>
+              <a:t>LOGISTIC REGRESSION — 82.1% ACCURACY</a:t>
             </a:r>
             <a:endParaRPr lang="en-US" sz="1100" dirty="0"/>
           </a:p>
@@ -7706,7 +7706,7 @@
                 <a:ea typeface="Calibri" panose="020F0502020204030204" pitchFamily="34" charset="-122"/>
                 <a:cs typeface="Calibri" panose="020F0502020204030204" pitchFamily="34" charset="-120"/>
               </a:rPr>
-              <a:t>RANDOM FOREST — 78.5% ACCURACY</a:t>
+              <a:t>RANDOM FOREST — 78.3% ACCURACY</a:t>
             </a:r>
             <a:endParaRPr lang="en-US" sz="1100" dirty="0"/>
           </a:p>
@@ -8091,7 +8091,7 @@
                           <a:ea typeface="Calibri" panose="020F0502020204030204" pitchFamily="34" charset="-122"/>
                           <a:cs typeface="Calibri" panose="020F0502020204030204" pitchFamily="34" charset="-120"/>
                         </a:rPr>
-                        <a:t>0.64</a:t>
+                        <a:t>0.57</a:t>
                       </a:r>
                       <a:endParaRPr lang="en-US" sz="1150" dirty="0">
                         <a:latin typeface="Calibri" panose="020F0502020204030204" pitchFamily="34" charset="0"/>
@@ -8156,7 +8156,7 @@
                           <a:ea typeface="Calibri" panose="020F0502020204030204" pitchFamily="34" charset="-122"/>
                           <a:cs typeface="Calibri" panose="020F0502020204030204" pitchFamily="34" charset="-120"/>
                         </a:rPr>
-                        <a:t>0.14</a:t>
+                        <a:t>0.13</a:t>
                       </a:r>
                       <a:endParaRPr lang="en-US" sz="1150" dirty="0">
                         <a:latin typeface="Calibri" panose="020F0502020204030204" pitchFamily="34" charset="0"/>
@@ -8221,7 +8221,7 @@
                           <a:ea typeface="Calibri" panose="020F0502020204030204" pitchFamily="34" charset="-122"/>
                           <a:cs typeface="Calibri" panose="020F0502020204030204" pitchFamily="34" charset="-120"/>
                         </a:rPr>
-                        <a:t>0.23</a:t>
+                        <a:t>0.21</a:t>
                       </a:r>
                       <a:endParaRPr lang="en-US" sz="1150" dirty="0">
                         <a:latin typeface="Calibri" panose="020F0502020204030204" pitchFamily="34" charset="0"/>
@@ -8353,7 +8353,7 @@
                           <a:ea typeface="Calibri" panose="020F0502020204030204" pitchFamily="34" charset="-122"/>
                           <a:cs typeface="Calibri" panose="020F0502020204030204" pitchFamily="34" charset="-120"/>
                         </a:rPr>
-                        <a:t>0.44</a:t>
+                        <a:t>0.47</a:t>
                       </a:r>
                       <a:endParaRPr lang="en-US" sz="1150" dirty="0">
                         <a:latin typeface="Calibri" panose="020F0502020204030204" pitchFamily="34" charset="0"/>
@@ -9278,7 +9278,7 @@
                 <a:ea typeface="Calibri" panose="020F0502020204030204" pitchFamily="34" charset="-122"/>
                 <a:cs typeface="Calibri" panose="020F0502020204030204" pitchFamily="34" charset="-120"/>
               </a:rPr>
-              <a:t>Class weights trade overall accuracy for minority-class recall: Logistic Regression Negative recall 0.41 → 0.58 and Neutral 0.23 → 0.49</a:t>
+              <a:t>Class weights help Logistic Regression most: Negative recall 0.41 → 0.57 and Neutral recall 0.23 → 0.49</a:t>
             </a:r>
             <a:endParaRPr lang="en-US" sz="1200" dirty="0"/>
           </a:p>
@@ -9299,7 +9299,7 @@
                 <a:ea typeface="Calibri" panose="020F0502020204030204" pitchFamily="34" charset="-122"/>
                 <a:cs typeface="Calibri" panose="020F0502020204030204" pitchFamily="34" charset="-120"/>
               </a:rPr>
-              <a:t>Macro F1 rises from 0.57 to 0.60 while accuracy drops from 82.0% to 77.1%</a:t>
+              <a:t>Macro F1 rises from 0.57 to 0.60 while accuracy drops from 82.1% to 77.0%</a:t>
             </a:r>
             <a:endParaRPr lang="en-US" sz="1200" dirty="0"/>
           </a:p>
@@ -9320,7 +9320,7 @@
                 <a:ea typeface="Calibri" panose="020F0502020204030204" pitchFamily="34" charset="-122"/>
                 <a:cs typeface="Calibri" panose="020F0502020204030204" pitchFamily="34" charset="-120"/>
               </a:rPr>
-              <a:t>Random Forest also gains on Negative reviews (recall 0.14 → 0.45) but still misses most Neutral ones</a:t>
+              <a:t>Random Forest barely reacts to class weights (Negative recall 0.13 → 0.15): it still predicts almost everything as Positive</a:t>
             </a:r>
             <a:endParaRPr lang="en-US" sz="1200" dirty="0"/>
           </a:p>
@@ -9341,7 +9341,7 @@
                 <a:ea typeface="Calibri" panose="020F0502020204030204" pitchFamily="34" charset="-122"/>
                 <a:cs typeface="Calibri" panose="020F0502020204030204" pitchFamily="34" charset="-120"/>
               </a:rPr>
-              <a:t>Neutral (3-star) reviews are mostly predicted as Positive (61% with plain Logistic Regression)</a:t>
+              <a:t>Neutral (3-star) reviews are mostly predicted as Positive (60% with plain Logistic Regression)</a:t>
             </a:r>
             <a:endParaRPr lang="en-US" sz="1200" dirty="0"/>
           </a:p>
@@ -9865,7 +9865,7 @@
                           <a:ea typeface="Calibri" panose="020F0502020204030204" pitchFamily="34" charset="-122"/>
                           <a:cs typeface="Calibri" panose="020F0502020204030204" pitchFamily="34" charset="-120"/>
                         </a:rPr>
-                        <a:t>82.0%</a:t>
+                        <a:t>82.1%</a:t>
                       </a:r>
                       <a:endParaRPr lang="en-US" sz="1150" dirty="0">
                         <a:latin typeface="Calibri" panose="020F0502020204030204" pitchFamily="34" charset="0"/>
@@ -10192,7 +10192,7 @@
                           <a:ea typeface="Calibri" panose="020F0502020204030204" pitchFamily="34" charset="-122"/>
                           <a:cs typeface="Calibri" panose="020F0502020204030204" pitchFamily="34" charset="-120"/>
                         </a:rPr>
-                        <a:t>77.1%</a:t>
+                        <a:t>77.0%</a:t>
                       </a:r>
                       <a:endParaRPr lang="en-US" sz="1150" dirty="0">
                         <a:latin typeface="Calibri" panose="020F0502020204030204" pitchFamily="34" charset="0"/>
@@ -10322,7 +10322,7 @@
                           <a:ea typeface="Calibri" panose="020F0502020204030204" pitchFamily="34" charset="-122"/>
                           <a:cs typeface="Calibri" panose="020F0502020204030204" pitchFamily="34" charset="-120"/>
                         </a:rPr>
-                        <a:t>0.58</a:t>
+                        <a:t>0.57</a:t>
                       </a:r>
                       <a:endParaRPr lang="en-US" sz="1150" dirty="0">
                         <a:latin typeface="Calibri" panose="020F0502020204030204" pitchFamily="34" charset="0"/>
@@ -10519,7 +10519,7 @@
                           <a:ea typeface="Calibri" panose="020F0502020204030204" pitchFamily="34" charset="-122"/>
                           <a:cs typeface="Calibri" panose="020F0502020204030204" pitchFamily="34" charset="-120"/>
                         </a:rPr>
-                        <a:t>78.5%</a:t>
+                        <a:t>78.3%</a:t>
                       </a:r>
                       <a:endParaRPr lang="en-US" sz="1150" dirty="0">
                         <a:latin typeface="Calibri" panose="020F0502020204030204" pitchFamily="34" charset="0"/>
@@ -10584,7 +10584,7 @@
                           <a:ea typeface="Calibri" panose="020F0502020204030204" pitchFamily="34" charset="-122"/>
                           <a:cs typeface="Calibri" panose="020F0502020204030204" pitchFamily="34" charset="-120"/>
                         </a:rPr>
-                        <a:t>0.39</a:t>
+                        <a:t>0.38</a:t>
                       </a:r>
                       <a:endParaRPr lang="en-US" sz="1150" dirty="0">
                         <a:latin typeface="Calibri" panose="020F0502020204030204" pitchFamily="34" charset="0"/>
@@ -10649,7 +10649,7 @@
                           <a:ea typeface="Calibri" panose="020F0502020204030204" pitchFamily="34" charset="-122"/>
                           <a:cs typeface="Calibri" panose="020F0502020204030204" pitchFamily="34" charset="-120"/>
                         </a:rPr>
-                        <a:t>0.14</a:t>
+                        <a:t>0.13</a:t>
                       </a:r>
                       <a:endParaRPr lang="en-US" sz="1150" dirty="0">
                         <a:latin typeface="Calibri" panose="020F0502020204030204" pitchFamily="34" charset="0"/>
@@ -10846,7 +10846,7 @@
                           <a:ea typeface="Calibri" panose="020F0502020204030204" pitchFamily="34" charset="-122"/>
                           <a:cs typeface="Calibri" panose="020F0502020204030204" pitchFamily="34" charset="-120"/>
                         </a:rPr>
-                        <a:t>81.0%</a:t>
+                        <a:t>78.7%</a:t>
                       </a:r>
                       <a:endParaRPr lang="en-US" sz="1150" dirty="0">
                         <a:latin typeface="Calibri" panose="020F0502020204030204" pitchFamily="34" charset="0"/>
@@ -10911,7 +10911,7 @@
                           <a:ea typeface="Calibri" panose="020F0502020204030204" pitchFamily="34" charset="-122"/>
                           <a:cs typeface="Calibri" panose="020F0502020204030204" pitchFamily="34" charset="-120"/>
                         </a:rPr>
-                        <a:t>0.56</a:t>
+                        <a:t>0.39</a:t>
                       </a:r>
                       <a:endParaRPr lang="en-US" sz="1150" dirty="0">
                         <a:latin typeface="Calibri" panose="020F0502020204030204" pitchFamily="34" charset="0"/>
@@ -10976,7 +10976,7 @@
                           <a:ea typeface="Calibri" panose="020F0502020204030204" pitchFamily="34" charset="-122"/>
                           <a:cs typeface="Calibri" panose="020F0502020204030204" pitchFamily="34" charset="-120"/>
                         </a:rPr>
-                        <a:t>0.45</a:t>
+                        <a:t>0.15</a:t>
                       </a:r>
                       <a:endParaRPr lang="en-US" sz="1150" dirty="0">
                         <a:latin typeface="Calibri" panose="020F0502020204030204" pitchFamily="34" charset="0"/>
@@ -11041,7 +11041,7 @@
                           <a:ea typeface="Calibri" panose="020F0502020204030204" pitchFamily="34" charset="-122"/>
                           <a:cs typeface="Calibri" panose="020F0502020204030204" pitchFamily="34" charset="-120"/>
                         </a:rPr>
-                        <a:t>0.22</a:t>
+                        <a:t>0.02</a:t>
                       </a:r>
                       <a:endParaRPr lang="en-US" sz="1150" dirty="0">
                         <a:latin typeface="Calibri" panose="020F0502020204030204" pitchFamily="34" charset="0"/>
@@ -11622,7 +11622,7 @@
                           <a:ea typeface="Calibri" panose="020F0502020204030204" pitchFamily="34" charset="-122"/>
                           <a:cs typeface="Calibri" panose="020F0502020204030204" pitchFamily="34" charset="-120"/>
                         </a:rPr>
-                        <a:t>0 (420)</a:t>
+                        <a:t>0 (544)</a:t>
                       </a:r>
                       <a:endParaRPr lang="en-US" sz="970" dirty="0">
                         <a:latin typeface="Calibri" panose="020F0502020204030204" pitchFamily="34" charset="0"/>
@@ -11752,7 +11752,7 @@
                           <a:ea typeface="Calibri" panose="020F0502020204030204" pitchFamily="34" charset="-122"/>
                           <a:cs typeface="Calibri" panose="020F0502020204030204" pitchFamily="34" charset="-120"/>
                         </a:rPr>
-                        <a:t>back, like, looks, looked, going, look, fabric, model, top, cute</a:t>
+                        <a:t>like, looked, looks, look, back, fabric, cheap, sweater, model, picture</a:t>
                       </a:r>
                       <a:endParaRPr lang="en-US" sz="970" dirty="0">
                         <a:latin typeface="Calibri" panose="020F0502020204030204" pitchFamily="34" charset="0"/>
@@ -11819,7 +11819,7 @@
                           <a:ea typeface="Calibri" panose="020F0502020204030204" pitchFamily="34" charset="-122"/>
                           <a:cs typeface="Calibri" panose="020F0502020204030204" pitchFamily="34" charset="-120"/>
                         </a:rPr>
-                        <a:t>1 (202)</a:t>
+                        <a:t>1 (191)</a:t>
                       </a:r>
                       <a:endParaRPr lang="en-US" sz="970" dirty="0">
                         <a:latin typeface="Calibri" panose="020F0502020204030204" pitchFamily="34" charset="0"/>
@@ -11949,7 +11949,7 @@
                           <a:ea typeface="Calibri" panose="020F0502020204030204" pitchFamily="34" charset="-122"/>
                           <a:cs typeface="Calibri" panose="020F0502020204030204" pitchFamily="34" charset="-120"/>
                         </a:rPr>
-                        <a:t>shirt, would, back, fabric, boxy, like, short, loved, top, look</a:t>
+                        <a:t>shirt, back, would, fabric, boxy, like, loved, thin, short, returning</a:t>
                       </a:r>
                       <a:endParaRPr lang="en-US" sz="970" dirty="0">
                         <a:latin typeface="Calibri" panose="020F0502020204030204" pitchFamily="34" charset="0"/>
@@ -12016,7 +12016,401 @@
                           <a:ea typeface="Calibri" panose="020F0502020204030204" pitchFamily="34" charset="-122"/>
                           <a:cs typeface="Calibri" panose="020F0502020204030204" pitchFamily="34" charset="-120"/>
                         </a:rPr>
-                        <a:t>2 (569)</a:t>
+                        <a:t>2 (428)</a:t>
+                      </a:r>
+                      <a:endParaRPr lang="en-US" sz="970" dirty="0">
+                        <a:latin typeface="Calibri" panose="020F0502020204030204" pitchFamily="34" charset="0"/>
+                        <a:ea typeface="Calibri" panose="020F0502020204030204" pitchFamily="34" charset="0"/>
+                        <a:cs typeface="Calibri" panose="020F0502020204030204" pitchFamily="34" charset="0"/>
+                      </a:endParaRPr>
+                    </a:p>
+                  </a:txBody>
+                  <a:tcPr>
+                    <a:lnL w="9525" cap="flat" cmpd="sng" algn="ctr">
+                      <a:solidFill>
+                        <a:srgbClr val="E2E6EC"/>
+                      </a:solidFill>
+                      <a:prstDash val="solid"/>
+                      <a:round/>
+                      <a:headEnd type="none" w="med" len="med"/>
+                      <a:tailEnd type="none" w="med" len="med"/>
+                    </a:lnL>
+                    <a:lnR w="9525" cap="flat" cmpd="sng" algn="ctr">
+                      <a:solidFill>
+                        <a:srgbClr val="E2E6EC"/>
+                      </a:solidFill>
+                      <a:prstDash val="solid"/>
+                      <a:round/>
+                      <a:headEnd type="none" w="med" len="med"/>
+                      <a:tailEnd type="none" w="med" len="med"/>
+                    </a:lnR>
+                    <a:lnT w="9525" cap="flat" cmpd="sng" algn="ctr">
+                      <a:solidFill>
+                        <a:srgbClr val="E2E6EC"/>
+                      </a:solidFill>
+                      <a:prstDash val="solid"/>
+                      <a:round/>
+                      <a:headEnd type="none" w="med" len="med"/>
+                      <a:tailEnd type="none" w="med" len="med"/>
+                    </a:lnT>
+                    <a:lnB w="9525" cap="flat" cmpd="sng" algn="ctr">
+                      <a:solidFill>
+                        <a:srgbClr val="E2E6EC"/>
+                      </a:solidFill>
+                      <a:prstDash val="solid"/>
+                      <a:round/>
+                      <a:headEnd type="none" w="med" len="med"/>
+                      <a:tailEnd type="none" w="med" len="med"/>
+                    </a:lnB>
+                  </a:tcPr>
+                </a:tc>
+                <a:tc>
+                  <a:txBody>
+                    <a:bodyPr/>
+                    <a:lstStyle/>
+                    <a:p>
+                      <a:pPr marL="0" indent="0">
+                        <a:buNone/>
+                      </a:pPr>
+                      <a:r>
+                        <a:rPr lang="en-US" sz="970" dirty="0">
+                          <a:solidFill>
+                            <a:srgbClr val="262626"/>
+                          </a:solidFill>
+                          <a:latin typeface="Calibri" panose="020F0502020204030204" pitchFamily="34" charset="0"/>
+                          <a:ea typeface="Calibri" panose="020F0502020204030204" pitchFamily="34" charset="-122"/>
+                          <a:cs typeface="Calibri" panose="020F0502020204030204" pitchFamily="34" charset="-120"/>
+                        </a:rPr>
+                        <a:t>Dress disappointment</a:t>
+                      </a:r>
+                      <a:endParaRPr lang="en-US" sz="970" dirty="0">
+                        <a:latin typeface="Calibri" panose="020F0502020204030204" pitchFamily="34" charset="0"/>
+                        <a:ea typeface="Calibri" panose="020F0502020204030204" pitchFamily="34" charset="0"/>
+                        <a:cs typeface="Calibri" panose="020F0502020204030204" pitchFamily="34" charset="0"/>
+                      </a:endParaRPr>
+                    </a:p>
+                  </a:txBody>
+                  <a:tcPr>
+                    <a:lnL w="9525" cap="flat" cmpd="sng" algn="ctr">
+                      <a:solidFill>
+                        <a:srgbClr val="E2E6EC"/>
+                      </a:solidFill>
+                      <a:prstDash val="solid"/>
+                      <a:round/>
+                      <a:headEnd type="none" w="med" len="med"/>
+                      <a:tailEnd type="none" w="med" len="med"/>
+                    </a:lnL>
+                    <a:lnR w="9525" cap="flat" cmpd="sng" algn="ctr">
+                      <a:solidFill>
+                        <a:srgbClr val="E2E6EC"/>
+                      </a:solidFill>
+                      <a:prstDash val="solid"/>
+                      <a:round/>
+                      <a:headEnd type="none" w="med" len="med"/>
+                      <a:tailEnd type="none" w="med" len="med"/>
+                    </a:lnR>
+                    <a:lnT w="9525" cap="flat" cmpd="sng" algn="ctr">
+                      <a:solidFill>
+                        <a:srgbClr val="E2E6EC"/>
+                      </a:solidFill>
+                      <a:prstDash val="solid"/>
+                      <a:round/>
+                      <a:headEnd type="none" w="med" len="med"/>
+                      <a:tailEnd type="none" w="med" len="med"/>
+                    </a:lnT>
+                    <a:lnB w="9525" cap="flat" cmpd="sng" algn="ctr">
+                      <a:solidFill>
+                        <a:srgbClr val="E2E6EC"/>
+                      </a:solidFill>
+                      <a:prstDash val="solid"/>
+                      <a:round/>
+                      <a:headEnd type="none" w="med" len="med"/>
+                      <a:tailEnd type="none" w="med" len="med"/>
+                    </a:lnB>
+                  </a:tcPr>
+                </a:tc>
+                <a:tc>
+                  <a:txBody>
+                    <a:bodyPr/>
+                    <a:lstStyle/>
+                    <a:p>
+                      <a:pPr marL="0" indent="0">
+                        <a:buNone/>
+                      </a:pPr>
+                      <a:r>
+                        <a:rPr lang="en-US" sz="970" dirty="0">
+                          <a:solidFill>
+                            <a:srgbClr val="262626"/>
+                          </a:solidFill>
+                          <a:latin typeface="Calibri" panose="020F0502020204030204" pitchFamily="34" charset="0"/>
+                          <a:ea typeface="Calibri" panose="020F0502020204030204" pitchFamily="34" charset="-122"/>
+                          <a:cs typeface="Calibri" panose="020F0502020204030204" pitchFamily="34" charset="-120"/>
+                        </a:rPr>
+                        <a:t>dress, like, would, fabric, back, disappointed, material, really, size, fit</a:t>
+                      </a:r>
+                      <a:endParaRPr lang="en-US" sz="970" dirty="0">
+                        <a:latin typeface="Calibri" panose="020F0502020204030204" pitchFamily="34" charset="0"/>
+                        <a:ea typeface="Calibri" panose="020F0502020204030204" pitchFamily="34" charset="0"/>
+                        <a:cs typeface="Calibri" panose="020F0502020204030204" pitchFamily="34" charset="0"/>
+                      </a:endParaRPr>
+                    </a:p>
+                  </a:txBody>
+                  <a:tcPr>
+                    <a:lnL w="9525" cap="flat" cmpd="sng" algn="ctr">
+                      <a:solidFill>
+                        <a:srgbClr val="E2E6EC"/>
+                      </a:solidFill>
+                      <a:prstDash val="solid"/>
+                      <a:round/>
+                      <a:headEnd type="none" w="med" len="med"/>
+                      <a:tailEnd type="none" w="med" len="med"/>
+                    </a:lnL>
+                    <a:lnR w="9525" cap="flat" cmpd="sng" algn="ctr">
+                      <a:solidFill>
+                        <a:srgbClr val="E2E6EC"/>
+                      </a:solidFill>
+                      <a:prstDash val="solid"/>
+                      <a:round/>
+                      <a:headEnd type="none" w="med" len="med"/>
+                      <a:tailEnd type="none" w="med" len="med"/>
+                    </a:lnR>
+                    <a:lnT w="9525" cap="flat" cmpd="sng" algn="ctr">
+                      <a:solidFill>
+                        <a:srgbClr val="E2E6EC"/>
+                      </a:solidFill>
+                      <a:prstDash val="solid"/>
+                      <a:round/>
+                      <a:headEnd type="none" w="med" len="med"/>
+                      <a:tailEnd type="none" w="med" len="med"/>
+                    </a:lnT>
+                    <a:lnB w="9525" cap="flat" cmpd="sng" algn="ctr">
+                      <a:solidFill>
+                        <a:srgbClr val="E2E6EC"/>
+                      </a:solidFill>
+                      <a:prstDash val="solid"/>
+                      <a:round/>
+                      <a:headEnd type="none" w="med" len="med"/>
+                      <a:tailEnd type="none" w="med" len="med"/>
+                    </a:lnB>
+                  </a:tcPr>
+                </a:tc>
+              </a:tr>
+              <a:tr h="518160">
+                <a:tc>
+                  <a:txBody>
+                    <a:bodyPr/>
+                    <a:lstStyle/>
+                    <a:p>
+                      <a:pPr marL="0" indent="0">
+                        <a:buNone/>
+                      </a:pPr>
+                      <a:r>
+                        <a:rPr lang="en-US" sz="970" dirty="0">
+                          <a:solidFill>
+                            <a:srgbClr val="262626"/>
+                          </a:solidFill>
+                          <a:latin typeface="Calibri" panose="020F0502020204030204" pitchFamily="34" charset="0"/>
+                          <a:ea typeface="Calibri" panose="020F0502020204030204" pitchFamily="34" charset="-122"/>
+                          <a:cs typeface="Calibri" panose="020F0502020204030204" pitchFamily="34" charset="-120"/>
+                        </a:rPr>
+                        <a:t>3 (735)</a:t>
+                      </a:r>
+                      <a:endParaRPr lang="en-US" sz="970" dirty="0">
+                        <a:latin typeface="Calibri" panose="020F0502020204030204" pitchFamily="34" charset="0"/>
+                        <a:ea typeface="Calibri" panose="020F0502020204030204" pitchFamily="34" charset="0"/>
+                        <a:cs typeface="Calibri" panose="020F0502020204030204" pitchFamily="34" charset="0"/>
+                      </a:endParaRPr>
+                    </a:p>
+                  </a:txBody>
+                  <a:tcPr>
+                    <a:lnL w="9525" cap="flat" cmpd="sng" algn="ctr">
+                      <a:solidFill>
+                        <a:srgbClr val="E2E6EC"/>
+                      </a:solidFill>
+                      <a:prstDash val="solid"/>
+                      <a:round/>
+                      <a:headEnd type="none" w="med" len="med"/>
+                      <a:tailEnd type="none" w="med" len="med"/>
+                    </a:lnL>
+                    <a:lnR w="9525" cap="flat" cmpd="sng" algn="ctr">
+                      <a:solidFill>
+                        <a:srgbClr val="E2E6EC"/>
+                      </a:solidFill>
+                      <a:prstDash val="solid"/>
+                      <a:round/>
+                      <a:headEnd type="none" w="med" len="med"/>
+                      <a:tailEnd type="none" w="med" len="med"/>
+                    </a:lnR>
+                    <a:lnT w="9525" cap="flat" cmpd="sng" algn="ctr">
+                      <a:solidFill>
+                        <a:srgbClr val="E2E6EC"/>
+                      </a:solidFill>
+                      <a:prstDash val="solid"/>
+                      <a:round/>
+                      <a:headEnd type="none" w="med" len="med"/>
+                      <a:tailEnd type="none" w="med" len="med"/>
+                    </a:lnT>
+                    <a:lnB w="9525" cap="flat" cmpd="sng" algn="ctr">
+                      <a:solidFill>
+                        <a:srgbClr val="E2E6EC"/>
+                      </a:solidFill>
+                      <a:prstDash val="solid"/>
+                      <a:round/>
+                      <a:headEnd type="none" w="med" len="med"/>
+                      <a:tailEnd type="none" w="med" len="med"/>
+                    </a:lnB>
+                  </a:tcPr>
+                </a:tc>
+                <a:tc>
+                  <a:txBody>
+                    <a:bodyPr/>
+                    <a:lstStyle/>
+                    <a:p>
+                      <a:pPr marL="0" indent="0">
+                        <a:buNone/>
+                      </a:pPr>
+                      <a:r>
+                        <a:rPr lang="en-US" sz="970" dirty="0">
+                          <a:solidFill>
+                            <a:srgbClr val="262626"/>
+                          </a:solidFill>
+                          <a:latin typeface="Calibri" panose="020F0502020204030204" pitchFamily="34" charset="0"/>
+                          <a:ea typeface="Calibri" panose="020F0502020204030204" pitchFamily="34" charset="-122"/>
+                          <a:cs typeface="Calibri" panose="020F0502020204030204" pitchFamily="34" charset="-120"/>
+                        </a:rPr>
+                        <a:t>Fabric / material quality</a:t>
+                      </a:r>
+                      <a:endParaRPr lang="en-US" sz="970" dirty="0">
+                        <a:latin typeface="Calibri" panose="020F0502020204030204" pitchFamily="34" charset="0"/>
+                        <a:ea typeface="Calibri" panose="020F0502020204030204" pitchFamily="34" charset="0"/>
+                        <a:cs typeface="Calibri" panose="020F0502020204030204" pitchFamily="34" charset="0"/>
+                      </a:endParaRPr>
+                    </a:p>
+                  </a:txBody>
+                  <a:tcPr>
+                    <a:lnL w="9525" cap="flat" cmpd="sng" algn="ctr">
+                      <a:solidFill>
+                        <a:srgbClr val="E2E6EC"/>
+                      </a:solidFill>
+                      <a:prstDash val="solid"/>
+                      <a:round/>
+                      <a:headEnd type="none" w="med" len="med"/>
+                      <a:tailEnd type="none" w="med" len="med"/>
+                    </a:lnL>
+                    <a:lnR w="9525" cap="flat" cmpd="sng" algn="ctr">
+                      <a:solidFill>
+                        <a:srgbClr val="E2E6EC"/>
+                      </a:solidFill>
+                      <a:prstDash val="solid"/>
+                      <a:round/>
+                      <a:headEnd type="none" w="med" len="med"/>
+                      <a:tailEnd type="none" w="med" len="med"/>
+                    </a:lnR>
+                    <a:lnT w="9525" cap="flat" cmpd="sng" algn="ctr">
+                      <a:solidFill>
+                        <a:srgbClr val="E2E6EC"/>
+                      </a:solidFill>
+                      <a:prstDash val="solid"/>
+                      <a:round/>
+                      <a:headEnd type="none" w="med" len="med"/>
+                      <a:tailEnd type="none" w="med" len="med"/>
+                    </a:lnT>
+                    <a:lnB w="9525" cap="flat" cmpd="sng" algn="ctr">
+                      <a:solidFill>
+                        <a:srgbClr val="E2E6EC"/>
+                      </a:solidFill>
+                      <a:prstDash val="solid"/>
+                      <a:round/>
+                      <a:headEnd type="none" w="med" len="med"/>
+                      <a:tailEnd type="none" w="med" len="med"/>
+                    </a:lnB>
+                  </a:tcPr>
+                </a:tc>
+                <a:tc>
+                  <a:txBody>
+                    <a:bodyPr/>
+                    <a:lstStyle/>
+                    <a:p>
+                      <a:pPr marL="0" indent="0">
+                        <a:buNone/>
+                      </a:pPr>
+                      <a:r>
+                        <a:rPr lang="en-US" sz="970" dirty="0">
+                          <a:solidFill>
+                            <a:srgbClr val="262626"/>
+                          </a:solidFill>
+                          <a:latin typeface="Calibri" panose="020F0502020204030204" pitchFamily="34" charset="0"/>
+                          <a:ea typeface="Calibri" panose="020F0502020204030204" pitchFamily="34" charset="-122"/>
+                          <a:cs typeface="Calibri" panose="020F0502020204030204" pitchFamily="34" charset="-120"/>
+                        </a:rPr>
+                        <a:t>quality, fabric, return, would, even, pants, one, could, thin, back</a:t>
+                      </a:r>
+                      <a:endParaRPr lang="en-US" sz="970" dirty="0">
+                        <a:latin typeface="Calibri" panose="020F0502020204030204" pitchFamily="34" charset="0"/>
+                        <a:ea typeface="Calibri" panose="020F0502020204030204" pitchFamily="34" charset="0"/>
+                        <a:cs typeface="Calibri" panose="020F0502020204030204" pitchFamily="34" charset="0"/>
+                      </a:endParaRPr>
+                    </a:p>
+                  </a:txBody>
+                  <a:tcPr>
+                    <a:lnL w="9525" cap="flat" cmpd="sng" algn="ctr">
+                      <a:solidFill>
+                        <a:srgbClr val="E2E6EC"/>
+                      </a:solidFill>
+                      <a:prstDash val="solid"/>
+                      <a:round/>
+                      <a:headEnd type="none" w="med" len="med"/>
+                      <a:tailEnd type="none" w="med" len="med"/>
+                    </a:lnL>
+                    <a:lnR w="9525" cap="flat" cmpd="sng" algn="ctr">
+                      <a:solidFill>
+                        <a:srgbClr val="E2E6EC"/>
+                      </a:solidFill>
+                      <a:prstDash val="solid"/>
+                      <a:round/>
+                      <a:headEnd type="none" w="med" len="med"/>
+                      <a:tailEnd type="none" w="med" len="med"/>
+                    </a:lnR>
+                    <a:lnT w="9525" cap="flat" cmpd="sng" algn="ctr">
+                      <a:solidFill>
+                        <a:srgbClr val="E2E6EC"/>
+                      </a:solidFill>
+                      <a:prstDash val="solid"/>
+                      <a:round/>
+                      <a:headEnd type="none" w="med" len="med"/>
+                      <a:tailEnd type="none" w="med" len="med"/>
+                    </a:lnT>
+                    <a:lnB w="9525" cap="flat" cmpd="sng" algn="ctr">
+                      <a:solidFill>
+                        <a:srgbClr val="E2E6EC"/>
+                      </a:solidFill>
+                      <a:prstDash val="solid"/>
+                      <a:round/>
+                      <a:headEnd type="none" w="med" len="med"/>
+                      <a:tailEnd type="none" w="med" len="med"/>
+                    </a:lnB>
+                  </a:tcPr>
+                </a:tc>
+              </a:tr>
+              <a:tr h="518160">
+                <a:tc>
+                  <a:txBody>
+                    <a:bodyPr/>
+                    <a:lstStyle/>
+                    <a:p>
+                      <a:pPr marL="0" indent="0">
+                        <a:buNone/>
+                      </a:pPr>
+                      <a:r>
+                        <a:rPr lang="en-US" sz="970" dirty="0">
+                          <a:solidFill>
+                            <a:srgbClr val="262626"/>
+                          </a:solidFill>
+                          <a:latin typeface="Calibri" panose="020F0502020204030204" pitchFamily="34" charset="0"/>
+                          <a:ea typeface="Calibri" panose="020F0502020204030204" pitchFamily="34" charset="-122"/>
+                          <a:cs typeface="Calibri" panose="020F0502020204030204" pitchFamily="34" charset="-120"/>
+                        </a:rPr>
+                        <a:t>4 (471)</a:t>
                       </a:r>
                       <a:endParaRPr lang="en-US" sz="970" dirty="0">
                         <a:latin typeface="Calibri" panose="020F0502020204030204" pitchFamily="34" charset="0"/>
@@ -12146,401 +12540,7 @@
                           <a:ea typeface="Calibri" panose="020F0502020204030204" pitchFamily="34" charset="-122"/>
                           <a:cs typeface="Calibri" panose="020F0502020204030204" pitchFamily="34" charset="-120"/>
                         </a:rPr>
-                        <a:t>top, small, size, would, ordered, fit, like, way, really, large</a:t>
-                      </a:r>
-                      <a:endParaRPr lang="en-US" sz="970" dirty="0">
-                        <a:latin typeface="Calibri" panose="020F0502020204030204" pitchFamily="34" charset="0"/>
-                        <a:ea typeface="Calibri" panose="020F0502020204030204" pitchFamily="34" charset="0"/>
-                        <a:cs typeface="Calibri" panose="020F0502020204030204" pitchFamily="34" charset="0"/>
-                      </a:endParaRPr>
-                    </a:p>
-                  </a:txBody>
-                  <a:tcPr>
-                    <a:lnL w="9525" cap="flat" cmpd="sng" algn="ctr">
-                      <a:solidFill>
-                        <a:srgbClr val="E2E6EC"/>
-                      </a:solidFill>
-                      <a:prstDash val="solid"/>
-                      <a:round/>
-                      <a:headEnd type="none" w="med" len="med"/>
-                      <a:tailEnd type="none" w="med" len="med"/>
-                    </a:lnL>
-                    <a:lnR w="9525" cap="flat" cmpd="sng" algn="ctr">
-                      <a:solidFill>
-                        <a:srgbClr val="E2E6EC"/>
-                      </a:solidFill>
-                      <a:prstDash val="solid"/>
-                      <a:round/>
-                      <a:headEnd type="none" w="med" len="med"/>
-                      <a:tailEnd type="none" w="med" len="med"/>
-                    </a:lnR>
-                    <a:lnT w="9525" cap="flat" cmpd="sng" algn="ctr">
-                      <a:solidFill>
-                        <a:srgbClr val="E2E6EC"/>
-                      </a:solidFill>
-                      <a:prstDash val="solid"/>
-                      <a:round/>
-                      <a:headEnd type="none" w="med" len="med"/>
-                      <a:tailEnd type="none" w="med" len="med"/>
-                    </a:lnT>
-                    <a:lnB w="9525" cap="flat" cmpd="sng" algn="ctr">
-                      <a:solidFill>
-                        <a:srgbClr val="E2E6EC"/>
-                      </a:solidFill>
-                      <a:prstDash val="solid"/>
-                      <a:round/>
-                      <a:headEnd type="none" w="med" len="med"/>
-                      <a:tailEnd type="none" w="med" len="med"/>
-                    </a:lnB>
-                  </a:tcPr>
-                </a:tc>
-              </a:tr>
-              <a:tr h="518160">
-                <a:tc>
-                  <a:txBody>
-                    <a:bodyPr/>
-                    <a:lstStyle/>
-                    <a:p>
-                      <a:pPr marL="0" indent="0">
-                        <a:buNone/>
-                      </a:pPr>
-                      <a:r>
-                        <a:rPr lang="en-US" sz="970" dirty="0">
-                          <a:solidFill>
-                            <a:srgbClr val="262626"/>
-                          </a:solidFill>
-                          <a:latin typeface="Calibri" panose="020F0502020204030204" pitchFamily="34" charset="0"/>
-                          <a:ea typeface="Calibri" panose="020F0502020204030204" pitchFamily="34" charset="-122"/>
-                          <a:cs typeface="Calibri" panose="020F0502020204030204" pitchFamily="34" charset="-120"/>
-                        </a:rPr>
-                        <a:t>3 (743)</a:t>
-                      </a:r>
-                      <a:endParaRPr lang="en-US" sz="970" dirty="0">
-                        <a:latin typeface="Calibri" panose="020F0502020204030204" pitchFamily="34" charset="0"/>
-                        <a:ea typeface="Calibri" panose="020F0502020204030204" pitchFamily="34" charset="0"/>
-                        <a:cs typeface="Calibri" panose="020F0502020204030204" pitchFamily="34" charset="0"/>
-                      </a:endParaRPr>
-                    </a:p>
-                  </a:txBody>
-                  <a:tcPr>
-                    <a:lnL w="9525" cap="flat" cmpd="sng" algn="ctr">
-                      <a:solidFill>
-                        <a:srgbClr val="E2E6EC"/>
-                      </a:solidFill>
-                      <a:prstDash val="solid"/>
-                      <a:round/>
-                      <a:headEnd type="none" w="med" len="med"/>
-                      <a:tailEnd type="none" w="med" len="med"/>
-                    </a:lnL>
-                    <a:lnR w="9525" cap="flat" cmpd="sng" algn="ctr">
-                      <a:solidFill>
-                        <a:srgbClr val="E2E6EC"/>
-                      </a:solidFill>
-                      <a:prstDash val="solid"/>
-                      <a:round/>
-                      <a:headEnd type="none" w="med" len="med"/>
-                      <a:tailEnd type="none" w="med" len="med"/>
-                    </a:lnR>
-                    <a:lnT w="9525" cap="flat" cmpd="sng" algn="ctr">
-                      <a:solidFill>
-                        <a:srgbClr val="E2E6EC"/>
-                      </a:solidFill>
-                      <a:prstDash val="solid"/>
-                      <a:round/>
-                      <a:headEnd type="none" w="med" len="med"/>
-                      <a:tailEnd type="none" w="med" len="med"/>
-                    </a:lnT>
-                    <a:lnB w="9525" cap="flat" cmpd="sng" algn="ctr">
-                      <a:solidFill>
-                        <a:srgbClr val="E2E6EC"/>
-                      </a:solidFill>
-                      <a:prstDash val="solid"/>
-                      <a:round/>
-                      <a:headEnd type="none" w="med" len="med"/>
-                      <a:tailEnd type="none" w="med" len="med"/>
-                    </a:lnB>
-                  </a:tcPr>
-                </a:tc>
-                <a:tc>
-                  <a:txBody>
-                    <a:bodyPr/>
-                    <a:lstStyle/>
-                    <a:p>
-                      <a:pPr marL="0" indent="0">
-                        <a:buNone/>
-                      </a:pPr>
-                      <a:r>
-                        <a:rPr lang="en-US" sz="970" dirty="0">
-                          <a:solidFill>
-                            <a:srgbClr val="262626"/>
-                          </a:solidFill>
-                          <a:latin typeface="Calibri" panose="020F0502020204030204" pitchFamily="34" charset="0"/>
-                          <a:ea typeface="Calibri" panose="020F0502020204030204" pitchFamily="34" charset="-122"/>
-                          <a:cs typeface="Calibri" panose="020F0502020204030204" pitchFamily="34" charset="-120"/>
-                        </a:rPr>
-                        <a:t>Fabric / material quality</a:t>
-                      </a:r>
-                      <a:endParaRPr lang="en-US" sz="970" dirty="0">
-                        <a:latin typeface="Calibri" panose="020F0502020204030204" pitchFamily="34" charset="0"/>
-                        <a:ea typeface="Calibri" panose="020F0502020204030204" pitchFamily="34" charset="0"/>
-                        <a:cs typeface="Calibri" panose="020F0502020204030204" pitchFamily="34" charset="0"/>
-                      </a:endParaRPr>
-                    </a:p>
-                  </a:txBody>
-                  <a:tcPr>
-                    <a:lnL w="9525" cap="flat" cmpd="sng" algn="ctr">
-                      <a:solidFill>
-                        <a:srgbClr val="E2E6EC"/>
-                      </a:solidFill>
-                      <a:prstDash val="solid"/>
-                      <a:round/>
-                      <a:headEnd type="none" w="med" len="med"/>
-                      <a:tailEnd type="none" w="med" len="med"/>
-                    </a:lnL>
-                    <a:lnR w="9525" cap="flat" cmpd="sng" algn="ctr">
-                      <a:solidFill>
-                        <a:srgbClr val="E2E6EC"/>
-                      </a:solidFill>
-                      <a:prstDash val="solid"/>
-                      <a:round/>
-                      <a:headEnd type="none" w="med" len="med"/>
-                      <a:tailEnd type="none" w="med" len="med"/>
-                    </a:lnR>
-                    <a:lnT w="9525" cap="flat" cmpd="sng" algn="ctr">
-                      <a:solidFill>
-                        <a:srgbClr val="E2E6EC"/>
-                      </a:solidFill>
-                      <a:prstDash val="solid"/>
-                      <a:round/>
-                      <a:headEnd type="none" w="med" len="med"/>
-                      <a:tailEnd type="none" w="med" len="med"/>
-                    </a:lnT>
-                    <a:lnB w="9525" cap="flat" cmpd="sng" algn="ctr">
-                      <a:solidFill>
-                        <a:srgbClr val="E2E6EC"/>
-                      </a:solidFill>
-                      <a:prstDash val="solid"/>
-                      <a:round/>
-                      <a:headEnd type="none" w="med" len="med"/>
-                      <a:tailEnd type="none" w="med" len="med"/>
-                    </a:lnB>
-                  </a:tcPr>
-                </a:tc>
-                <a:tc>
-                  <a:txBody>
-                    <a:bodyPr/>
-                    <a:lstStyle/>
-                    <a:p>
-                      <a:pPr marL="0" indent="0">
-                        <a:buNone/>
-                      </a:pPr>
-                      <a:r>
-                        <a:rPr lang="en-US" sz="970" dirty="0">
-                          <a:solidFill>
-                            <a:srgbClr val="262626"/>
-                          </a:solidFill>
-                          <a:latin typeface="Calibri" panose="020F0502020204030204" pitchFamily="34" charset="0"/>
-                          <a:ea typeface="Calibri" panose="020F0502020204030204" pitchFamily="34" charset="-122"/>
-                          <a:cs typeface="Calibri" panose="020F0502020204030204" pitchFamily="34" charset="-120"/>
-                        </a:rPr>
-                        <a:t>quality, fabric, material, cheap, sweater, thin, price, like, even, would</a:t>
-                      </a:r>
-                      <a:endParaRPr lang="en-US" sz="970" dirty="0">
-                        <a:latin typeface="Calibri" panose="020F0502020204030204" pitchFamily="34" charset="0"/>
-                        <a:ea typeface="Calibri" panose="020F0502020204030204" pitchFamily="34" charset="0"/>
-                        <a:cs typeface="Calibri" panose="020F0502020204030204" pitchFamily="34" charset="0"/>
-                      </a:endParaRPr>
-                    </a:p>
-                  </a:txBody>
-                  <a:tcPr>
-                    <a:lnL w="9525" cap="flat" cmpd="sng" algn="ctr">
-                      <a:solidFill>
-                        <a:srgbClr val="E2E6EC"/>
-                      </a:solidFill>
-                      <a:prstDash val="solid"/>
-                      <a:round/>
-                      <a:headEnd type="none" w="med" len="med"/>
-                      <a:tailEnd type="none" w="med" len="med"/>
-                    </a:lnL>
-                    <a:lnR w="9525" cap="flat" cmpd="sng" algn="ctr">
-                      <a:solidFill>
-                        <a:srgbClr val="E2E6EC"/>
-                      </a:solidFill>
-                      <a:prstDash val="solid"/>
-                      <a:round/>
-                      <a:headEnd type="none" w="med" len="med"/>
-                      <a:tailEnd type="none" w="med" len="med"/>
-                    </a:lnR>
-                    <a:lnT w="9525" cap="flat" cmpd="sng" algn="ctr">
-                      <a:solidFill>
-                        <a:srgbClr val="E2E6EC"/>
-                      </a:solidFill>
-                      <a:prstDash val="solid"/>
-                      <a:round/>
-                      <a:headEnd type="none" w="med" len="med"/>
-                      <a:tailEnd type="none" w="med" len="med"/>
-                    </a:lnT>
-                    <a:lnB w="9525" cap="flat" cmpd="sng" algn="ctr">
-                      <a:solidFill>
-                        <a:srgbClr val="E2E6EC"/>
-                      </a:solidFill>
-                      <a:prstDash val="solid"/>
-                      <a:round/>
-                      <a:headEnd type="none" w="med" len="med"/>
-                      <a:tailEnd type="none" w="med" len="med"/>
-                    </a:lnB>
-                  </a:tcPr>
-                </a:tc>
-              </a:tr>
-              <a:tr h="518160">
-                <a:tc>
-                  <a:txBody>
-                    <a:bodyPr/>
-                    <a:lstStyle/>
-                    <a:p>
-                      <a:pPr marL="0" indent="0">
-                        <a:buNone/>
-                      </a:pPr>
-                      <a:r>
-                        <a:rPr lang="en-US" sz="970" dirty="0">
-                          <a:solidFill>
-                            <a:srgbClr val="262626"/>
-                          </a:solidFill>
-                          <a:latin typeface="Calibri" panose="020F0502020204030204" pitchFamily="34" charset="0"/>
-                          <a:ea typeface="Calibri" panose="020F0502020204030204" pitchFamily="34" charset="-122"/>
-                          <a:cs typeface="Calibri" panose="020F0502020204030204" pitchFamily="34" charset="-120"/>
-                        </a:rPr>
-                        <a:t>4 (435)</a:t>
-                      </a:r>
-                      <a:endParaRPr lang="en-US" sz="970" dirty="0">
-                        <a:latin typeface="Calibri" panose="020F0502020204030204" pitchFamily="34" charset="0"/>
-                        <a:ea typeface="Calibri" panose="020F0502020204030204" pitchFamily="34" charset="0"/>
-                        <a:cs typeface="Calibri" panose="020F0502020204030204" pitchFamily="34" charset="0"/>
-                      </a:endParaRPr>
-                    </a:p>
-                  </a:txBody>
-                  <a:tcPr>
-                    <a:lnL w="9525" cap="flat" cmpd="sng" algn="ctr">
-                      <a:solidFill>
-                        <a:srgbClr val="E2E6EC"/>
-                      </a:solidFill>
-                      <a:prstDash val="solid"/>
-                      <a:round/>
-                      <a:headEnd type="none" w="med" len="med"/>
-                      <a:tailEnd type="none" w="med" len="med"/>
-                    </a:lnL>
-                    <a:lnR w="9525" cap="flat" cmpd="sng" algn="ctr">
-                      <a:solidFill>
-                        <a:srgbClr val="E2E6EC"/>
-                      </a:solidFill>
-                      <a:prstDash val="solid"/>
-                      <a:round/>
-                      <a:headEnd type="none" w="med" len="med"/>
-                      <a:tailEnd type="none" w="med" len="med"/>
-                    </a:lnR>
-                    <a:lnT w="9525" cap="flat" cmpd="sng" algn="ctr">
-                      <a:solidFill>
-                        <a:srgbClr val="E2E6EC"/>
-                      </a:solidFill>
-                      <a:prstDash val="solid"/>
-                      <a:round/>
-                      <a:headEnd type="none" w="med" len="med"/>
-                      <a:tailEnd type="none" w="med" len="med"/>
-                    </a:lnT>
-                    <a:lnB w="9525" cap="flat" cmpd="sng" algn="ctr">
-                      <a:solidFill>
-                        <a:srgbClr val="E2E6EC"/>
-                      </a:solidFill>
-                      <a:prstDash val="solid"/>
-                      <a:round/>
-                      <a:headEnd type="none" w="med" len="med"/>
-                      <a:tailEnd type="none" w="med" len="med"/>
-                    </a:lnB>
-                  </a:tcPr>
-                </a:tc>
-                <a:tc>
-                  <a:txBody>
-                    <a:bodyPr/>
-                    <a:lstStyle/>
-                    <a:p>
-                      <a:pPr marL="0" indent="0">
-                        <a:buNone/>
-                      </a:pPr>
-                      <a:r>
-                        <a:rPr lang="en-US" sz="970" dirty="0">
-                          <a:solidFill>
-                            <a:srgbClr val="262626"/>
-                          </a:solidFill>
-                          <a:latin typeface="Calibri" panose="020F0502020204030204" pitchFamily="34" charset="0"/>
-                          <a:ea typeface="Calibri" panose="020F0502020204030204" pitchFamily="34" charset="-122"/>
-                          <a:cs typeface="Calibri" panose="020F0502020204030204" pitchFamily="34" charset="-120"/>
-                        </a:rPr>
-                        <a:t>Dress disappointment</a:t>
-                      </a:r>
-                      <a:endParaRPr lang="en-US" sz="970" dirty="0">
-                        <a:latin typeface="Calibri" panose="020F0502020204030204" pitchFamily="34" charset="0"/>
-                        <a:ea typeface="Calibri" panose="020F0502020204030204" pitchFamily="34" charset="0"/>
-                        <a:cs typeface="Calibri" panose="020F0502020204030204" pitchFamily="34" charset="0"/>
-                      </a:endParaRPr>
-                    </a:p>
-                  </a:txBody>
-                  <a:tcPr>
-                    <a:lnL w="9525" cap="flat" cmpd="sng" algn="ctr">
-                      <a:solidFill>
-                        <a:srgbClr val="E2E6EC"/>
-                      </a:solidFill>
-                      <a:prstDash val="solid"/>
-                      <a:round/>
-                      <a:headEnd type="none" w="med" len="med"/>
-                      <a:tailEnd type="none" w="med" len="med"/>
-                    </a:lnL>
-                    <a:lnR w="9525" cap="flat" cmpd="sng" algn="ctr">
-                      <a:solidFill>
-                        <a:srgbClr val="E2E6EC"/>
-                      </a:solidFill>
-                      <a:prstDash val="solid"/>
-                      <a:round/>
-                      <a:headEnd type="none" w="med" len="med"/>
-                      <a:tailEnd type="none" w="med" len="med"/>
-                    </a:lnR>
-                    <a:lnT w="9525" cap="flat" cmpd="sng" algn="ctr">
-                      <a:solidFill>
-                        <a:srgbClr val="E2E6EC"/>
-                      </a:solidFill>
-                      <a:prstDash val="solid"/>
-                      <a:round/>
-                      <a:headEnd type="none" w="med" len="med"/>
-                      <a:tailEnd type="none" w="med" len="med"/>
-                    </a:lnT>
-                    <a:lnB w="9525" cap="flat" cmpd="sng" algn="ctr">
-                      <a:solidFill>
-                        <a:srgbClr val="E2E6EC"/>
-                      </a:solidFill>
-                      <a:prstDash val="solid"/>
-                      <a:round/>
-                      <a:headEnd type="none" w="med" len="med"/>
-                      <a:tailEnd type="none" w="med" len="med"/>
-                    </a:lnB>
-                  </a:tcPr>
-                </a:tc>
-                <a:tc>
-                  <a:txBody>
-                    <a:bodyPr/>
-                    <a:lstStyle/>
-                    <a:p>
-                      <a:pPr marL="0" indent="0">
-                        <a:buNone/>
-                      </a:pPr>
-                      <a:r>
-                        <a:rPr lang="en-US" sz="970" dirty="0">
-                          <a:solidFill>
-                            <a:srgbClr val="262626"/>
-                          </a:solidFill>
-                          <a:latin typeface="Calibri" panose="020F0502020204030204" pitchFamily="34" charset="0"/>
-                          <a:ea typeface="Calibri" panose="020F0502020204030204" pitchFamily="34" charset="-122"/>
-                          <a:cs typeface="Calibri" panose="020F0502020204030204" pitchFamily="34" charset="-120"/>
-                        </a:rPr>
-                        <a:t>dress, like, fabric, would, really, disappointed, look, looked, material, could</a:t>
+                        <a:t>top, small, size, ordered, would, fit, large, like, way, really</a:t>
                       </a:r>
                       <a:endParaRPr lang="en-US" sz="970" dirty="0">
                         <a:latin typeface="Calibri" panose="020F0502020204030204" pitchFamily="34" charset="0"/>

</xml_diff>